<commit_message>
Ajout d'une image à la présentation.
</commit_message>
<xml_diff>
--- a/PALEOCLIMATOLOGIE_presentation_DU_PROEJET.pptx
+++ b/PALEOCLIMATOLOGIE_presentation_DU_PROEJET.pptx
@@ -136,6 +136,89 @@
 </p:presentation>
 </file>
 
+<file path=ppt/revisionInfo.xml><?xml version="1.0" encoding="utf-8"?>
+<p1510:revInfo xmlns:a="http://schemas.openxmlformats.org/drawingml/2006/main" xmlns:r="http://schemas.openxmlformats.org/officeDocument/2006/relationships" xmlns:p1510="http://schemas.microsoft.com/office/powerpoint/2015/10/main">
+  <p1510:revLst>
+    <p1510:client id="{49065972-5317-42B7-8774-121C1DC3676C}" v="7" dt="2025-05-19T10:21:23.856"/>
+  </p1510:revLst>
+</p1510:revInfo>
+</file>
+
+<file path=ppt/changesInfos/changesInfo1.xml><?xml version="1.0" encoding="utf-8"?>
+<pc:chgInfo xmlns:a="http://schemas.openxmlformats.org/drawingml/2006/main" xmlns:r="http://schemas.openxmlformats.org/officeDocument/2006/relationships" xmlns:ac="http://schemas.microsoft.com/office/drawing/2013/main/command" xmlns:pc="http://schemas.microsoft.com/office/powerpoint/2013/main/command">
+  <pc:docChgLst>
+    <pc:chgData name="Maxime Saffon" userId="25515bfe69c2a72d" providerId="LiveId" clId="{49065972-5317-42B7-8774-121C1DC3676C}"/>
+    <pc:docChg chg="custSel modSld">
+      <pc:chgData name="Maxime Saffon" userId="25515bfe69c2a72d" providerId="LiveId" clId="{49065972-5317-42B7-8774-121C1DC3676C}" dt="2025-05-19T10:21:23.856" v="11" actId="1076"/>
+      <pc:docMkLst>
+        <pc:docMk/>
+      </pc:docMkLst>
+      <pc:sldChg chg="modSp mod">
+        <pc:chgData name="Maxime Saffon" userId="25515bfe69c2a72d" providerId="LiveId" clId="{49065972-5317-42B7-8774-121C1DC3676C}" dt="2025-05-19T10:19:42.298" v="1" actId="13926"/>
+        <pc:sldMkLst>
+          <pc:docMk/>
+          <pc:sldMk cId="4021005611" sldId="256"/>
+        </pc:sldMkLst>
+        <pc:spChg chg="mod">
+          <ac:chgData name="Maxime Saffon" userId="25515bfe69c2a72d" providerId="LiveId" clId="{49065972-5317-42B7-8774-121C1DC3676C}" dt="2025-05-19T10:19:42.298" v="1" actId="13926"/>
+          <ac:spMkLst>
+            <pc:docMk/>
+            <pc:sldMk cId="4021005611" sldId="256"/>
+            <ac:spMk id="3" creationId="{BB7162E2-F2C2-FE4B-48B0-4A5B3F9B9CAC}"/>
+          </ac:spMkLst>
+        </pc:spChg>
+      </pc:sldChg>
+      <pc:sldChg chg="modSp mod">
+        <pc:chgData name="Maxime Saffon" userId="25515bfe69c2a72d" providerId="LiveId" clId="{49065972-5317-42B7-8774-121C1DC3676C}" dt="2025-05-19T10:19:57.748" v="2" actId="1076"/>
+        <pc:sldMkLst>
+          <pc:docMk/>
+          <pc:sldMk cId="164036177" sldId="262"/>
+        </pc:sldMkLst>
+        <pc:spChg chg="mod">
+          <ac:chgData name="Maxime Saffon" userId="25515bfe69c2a72d" providerId="LiveId" clId="{49065972-5317-42B7-8774-121C1DC3676C}" dt="2025-05-19T10:19:57.748" v="2" actId="1076"/>
+          <ac:spMkLst>
+            <pc:docMk/>
+            <pc:sldMk cId="164036177" sldId="262"/>
+            <ac:spMk id="31" creationId="{4746ADEB-4AC1-E1DB-D97E-E542DCD12150}"/>
+          </ac:spMkLst>
+        </pc:spChg>
+      </pc:sldChg>
+      <pc:sldChg chg="addSp delSp modSp mod">
+        <pc:chgData name="Maxime Saffon" userId="25515bfe69c2a72d" providerId="LiveId" clId="{49065972-5317-42B7-8774-121C1DC3676C}" dt="2025-05-19T10:21:23.856" v="11" actId="1076"/>
+        <pc:sldMkLst>
+          <pc:docMk/>
+          <pc:sldMk cId="2543521050" sldId="267"/>
+        </pc:sldMkLst>
+        <pc:spChg chg="del mod">
+          <ac:chgData name="Maxime Saffon" userId="25515bfe69c2a72d" providerId="LiveId" clId="{49065972-5317-42B7-8774-121C1DC3676C}" dt="2025-05-19T10:20:55.425" v="5" actId="478"/>
+          <ac:spMkLst>
+            <pc:docMk/>
+            <pc:sldMk cId="2543521050" sldId="267"/>
+            <ac:spMk id="6" creationId="{023A00A0-F05B-9CF8-DB5A-314C7DE13CE2}"/>
+          </ac:spMkLst>
+        </pc:spChg>
+        <pc:picChg chg="add del mod">
+          <ac:chgData name="Maxime Saffon" userId="25515bfe69c2a72d" providerId="LiveId" clId="{49065972-5317-42B7-8774-121C1DC3676C}" dt="2025-05-19T10:21:17.838" v="8" actId="478"/>
+          <ac:picMkLst>
+            <pc:docMk/>
+            <pc:sldMk cId="2543521050" sldId="267"/>
+            <ac:picMk id="1026" creationId="{E07A7923-20A0-9D11-2BD4-EB27B8F84EC1}"/>
+          </ac:picMkLst>
+        </pc:picChg>
+        <pc:picChg chg="add mod">
+          <ac:chgData name="Maxime Saffon" userId="25515bfe69c2a72d" providerId="LiveId" clId="{49065972-5317-42B7-8774-121C1DC3676C}" dt="2025-05-19T10:21:23.856" v="11" actId="1076"/>
+          <ac:picMkLst>
+            <pc:docMk/>
+            <pc:sldMk cId="2543521050" sldId="267"/>
+            <ac:picMk id="1028" creationId="{F637F614-F401-8D82-3007-C77FC7EFC303}"/>
+          </ac:picMkLst>
+        </pc:picChg>
+      </pc:sldChg>
+    </pc:docChg>
+  </pc:docChgLst>
+</pc:chgInfo>
+</file>
+
 <file path=ppt/slideLayouts/slideLayout1.xml><?xml version="1.0" encoding="utf-8"?>
 <p:sldLayout xmlns:a="http://schemas.openxmlformats.org/drawingml/2006/main" xmlns:r="http://schemas.openxmlformats.org/officeDocument/2006/relationships" xmlns:p="http://schemas.openxmlformats.org/presentationml/2006/main" type="title" preserve="1">
   <p:cSld name="Title Slide">
@@ -339,7 +422,7 @@
           <a:p>
             <a:fld id="{75F6E9B1-877C-411B-87E3-717BA5B5A813}" type="slidenum">
               <a:rPr lang="en-HK" smtClean="0"/>
-              <a:t>‹N°›</a:t>
+              <a:t>‹#›</a:t>
             </a:fld>
             <a:endParaRPr lang="en-HK"/>
           </a:p>
@@ -539,7 +622,7 @@
           <a:p>
             <a:fld id="{75F6E9B1-877C-411B-87E3-717BA5B5A813}" type="slidenum">
               <a:rPr lang="en-HK" smtClean="0"/>
-              <a:t>‹N°›</a:t>
+              <a:t>‹#›</a:t>
             </a:fld>
             <a:endParaRPr lang="en-HK"/>
           </a:p>
@@ -749,7 +832,7 @@
           <a:p>
             <a:fld id="{75F6E9B1-877C-411B-87E3-717BA5B5A813}" type="slidenum">
               <a:rPr lang="en-HK" smtClean="0"/>
-              <a:t>‹N°›</a:t>
+              <a:t>‹#›</a:t>
             </a:fld>
             <a:endParaRPr lang="en-HK"/>
           </a:p>
@@ -949,7 +1032,7 @@
           <a:p>
             <a:fld id="{75F6E9B1-877C-411B-87E3-717BA5B5A813}" type="slidenum">
               <a:rPr lang="en-HK" smtClean="0"/>
-              <a:t>‹N°›</a:t>
+              <a:t>‹#›</a:t>
             </a:fld>
             <a:endParaRPr lang="en-HK"/>
           </a:p>
@@ -1225,7 +1308,7 @@
           <a:p>
             <a:fld id="{75F6E9B1-877C-411B-87E3-717BA5B5A813}" type="slidenum">
               <a:rPr lang="en-HK" smtClean="0"/>
-              <a:t>‹N°›</a:t>
+              <a:t>‹#›</a:t>
             </a:fld>
             <a:endParaRPr lang="en-HK"/>
           </a:p>
@@ -1493,7 +1576,7 @@
           <a:p>
             <a:fld id="{75F6E9B1-877C-411B-87E3-717BA5B5A813}" type="slidenum">
               <a:rPr lang="en-HK" smtClean="0"/>
-              <a:t>‹N°›</a:t>
+              <a:t>‹#›</a:t>
             </a:fld>
             <a:endParaRPr lang="en-HK"/>
           </a:p>
@@ -1908,7 +1991,7 @@
           <a:p>
             <a:fld id="{75F6E9B1-877C-411B-87E3-717BA5B5A813}" type="slidenum">
               <a:rPr lang="en-HK" smtClean="0"/>
-              <a:t>‹N°›</a:t>
+              <a:t>‹#›</a:t>
             </a:fld>
             <a:endParaRPr lang="en-HK"/>
           </a:p>
@@ -2050,7 +2133,7 @@
           <a:p>
             <a:fld id="{75F6E9B1-877C-411B-87E3-717BA5B5A813}" type="slidenum">
               <a:rPr lang="en-HK" smtClean="0"/>
-              <a:t>‹N°›</a:t>
+              <a:t>‹#›</a:t>
             </a:fld>
             <a:endParaRPr lang="en-HK"/>
           </a:p>
@@ -2163,7 +2246,7 @@
           <a:p>
             <a:fld id="{75F6E9B1-877C-411B-87E3-717BA5B5A813}" type="slidenum">
               <a:rPr lang="en-HK" smtClean="0"/>
-              <a:t>‹N°›</a:t>
+              <a:t>‹#›</a:t>
             </a:fld>
             <a:endParaRPr lang="en-HK"/>
           </a:p>
@@ -2476,7 +2559,7 @@
           <a:p>
             <a:fld id="{75F6E9B1-877C-411B-87E3-717BA5B5A813}" type="slidenum">
               <a:rPr lang="en-HK" smtClean="0"/>
-              <a:t>‹N°›</a:t>
+              <a:t>‹#›</a:t>
             </a:fld>
             <a:endParaRPr lang="en-HK"/>
           </a:p>
@@ -2765,7 +2848,7 @@
           <a:p>
             <a:fld id="{75F6E9B1-877C-411B-87E3-717BA5B5A813}" type="slidenum">
               <a:rPr lang="en-HK" smtClean="0"/>
-              <a:t>‹N°›</a:t>
+              <a:t>‹#›</a:t>
             </a:fld>
             <a:endParaRPr lang="en-HK"/>
           </a:p>
@@ -3044,7 +3127,7 @@
           <a:p>
             <a:fld id="{75F6E9B1-877C-411B-87E3-717BA5B5A813}" type="slidenum">
               <a:rPr lang="en-HK" smtClean="0"/>
-              <a:t>‹N°›</a:t>
+              <a:t>‹#›</a:t>
             </a:fld>
             <a:endParaRPr lang="en-HK"/>
           </a:p>
@@ -9664,7 +9747,7 @@
         </p:nvSpPr>
         <p:spPr>
           <a:xfrm>
-            <a:off x="6096000" y="5776198"/>
+            <a:off x="6096000" y="6053197"/>
             <a:ext cx="1040734" cy="369332"/>
           </a:xfrm>
           <a:prstGeom prst="rect">
@@ -11432,42 +11515,53 @@
           </a:prstGeom>
         </p:spPr>
       </p:pic>
-      <p:sp>
-        <p:nvSpPr>
-          <p:cNvPr id="6" name="TextBox 5">
-            <a:extLst>
-              <a:ext uri="{FF2B5EF4-FFF2-40B4-BE49-F238E27FC236}">
-                <a16:creationId xmlns:a16="http://schemas.microsoft.com/office/drawing/2014/main" id="{023A00A0-F05B-9CF8-DB5A-314C7DE13CE2}"/>
-              </a:ext>
-            </a:extLst>
-          </p:cNvPr>
-          <p:cNvSpPr txBox="1"/>
-          <p:nvPr/>
-        </p:nvSpPr>
-        <p:spPr>
-          <a:xfrm>
-            <a:off x="1636776" y="4451044"/>
-            <a:ext cx="3035831" cy="369332"/>
+      <p:pic>
+        <p:nvPicPr>
+          <p:cNvPr id="1028" name="Picture 4" descr="Histoire du climat depuis l'an Mil | Emmanuel Le Roy Ladurie - Librairie  KOEGUI">
+            <a:extLst>
+              <a:ext uri="{FF2B5EF4-FFF2-40B4-BE49-F238E27FC236}">
+                <a16:creationId xmlns:a16="http://schemas.microsoft.com/office/drawing/2014/main" id="{F637F614-F401-8D82-3007-C77FC7EFC303}"/>
+              </a:ext>
+            </a:extLst>
+          </p:cNvPr>
+          <p:cNvPicPr>
+            <a:picLocks noChangeAspect="1" noChangeArrowheads="1"/>
+          </p:cNvPicPr>
+          <p:nvPr/>
+        </p:nvPicPr>
+        <p:blipFill>
+          <a:blip r:embed="rId4">
+            <a:extLst>
+              <a:ext uri="{28A0092B-C50C-407E-A947-70E740481C1C}">
+                <a14:useLocalDpi xmlns:a14="http://schemas.microsoft.com/office/drawing/2010/main" val="0"/>
+              </a:ext>
+            </a:extLst>
+          </a:blip>
+          <a:srcRect/>
+          <a:stretch>
+            <a:fillRect/>
+          </a:stretch>
+        </p:blipFill>
+        <p:spPr bwMode="auto">
+          <a:xfrm>
+            <a:off x="1882570" y="2747963"/>
+            <a:ext cx="3240088" cy="3429000"/>
           </a:xfrm>
           <a:prstGeom prst="rect">
             <a:avLst/>
           </a:prstGeom>
           <a:noFill/>
-        </p:spPr>
-        <p:txBody>
-          <a:bodyPr wrap="none" rtlCol="0">
-            <a:spAutoFit/>
-          </a:bodyPr>
-          <a:lstStyle/>
-          <a:p>
-            <a:r>
-              <a:rPr lang="fr-FR" b="1" dirty="0"/>
-              <a:t>IMAGE DU LIVRE DE CIBLAT</a:t>
-            </a:r>
-            <a:endParaRPr lang="en-HK" b="1" dirty="0"/>
-          </a:p>
-        </p:txBody>
-      </p:sp>
+          <a:extLst>
+            <a:ext uri="{909E8E84-426E-40DD-AFC4-6F175D3DCCD1}">
+              <a14:hiddenFill xmlns:a14="http://schemas.microsoft.com/office/drawing/2010/main">
+                <a:solidFill>
+                  <a:srgbClr val="FFFFFF"/>
+                </a:solidFill>
+              </a14:hiddenFill>
+            </a:ext>
+          </a:extLst>
+        </p:spPr>
+      </p:pic>
     </p:spTree>
     <p:extLst>
       <p:ext uri="{BB962C8B-B14F-4D97-AF65-F5344CB8AC3E}">

</xml_diff>

<commit_message>
AJout du moyennage pour la suisse.
</commit_message>
<xml_diff>
--- a/PALEOCLIMATOLOGIE_presentation_DU_PROEJET.pptx
+++ b/PALEOCLIMATOLOGIE_presentation_DU_PROEJET.pptx
@@ -139,7 +139,7 @@
 <file path=ppt/revisionInfo.xml><?xml version="1.0" encoding="utf-8"?>
 <p1510:revInfo xmlns:a="http://schemas.openxmlformats.org/drawingml/2006/main" xmlns:r="http://schemas.openxmlformats.org/officeDocument/2006/relationships" xmlns:p1510="http://schemas.microsoft.com/office/powerpoint/2015/10/main">
   <p1510:revLst>
-    <p1510:client id="{49065972-5317-42B7-8774-121C1DC3676C}" v="7" dt="2025-05-19T10:21:23.856"/>
+    <p1510:client id="{49065972-5317-42B7-8774-121C1DC3676C}" v="12" dt="2025-05-26T12:46:06.839"/>
   </p1510:revLst>
 </p1510:revInfo>
 </file>
@@ -148,8 +148,8 @@
 <pc:chgInfo xmlns:a="http://schemas.openxmlformats.org/drawingml/2006/main" xmlns:r="http://schemas.openxmlformats.org/officeDocument/2006/relationships" xmlns:ac="http://schemas.microsoft.com/office/drawing/2013/main/command" xmlns:pc="http://schemas.microsoft.com/office/powerpoint/2013/main/command">
   <pc:docChgLst>
     <pc:chgData name="Maxime Saffon" userId="25515bfe69c2a72d" providerId="LiveId" clId="{49065972-5317-42B7-8774-121C1DC3676C}"/>
-    <pc:docChg chg="custSel modSld">
-      <pc:chgData name="Maxime Saffon" userId="25515bfe69c2a72d" providerId="LiveId" clId="{49065972-5317-42B7-8774-121C1DC3676C}" dt="2025-05-19T10:21:23.856" v="11" actId="1076"/>
+    <pc:docChg chg="undo custSel modSld">
+      <pc:chgData name="Maxime Saffon" userId="25515bfe69c2a72d" providerId="LiveId" clId="{49065972-5317-42B7-8774-121C1DC3676C}" dt="2025-05-26T12:46:06.839" v="33" actId="1076"/>
       <pc:docMkLst>
         <pc:docMk/>
       </pc:docMkLst>
@@ -189,28 +189,42 @@
           <pc:docMk/>
           <pc:sldMk cId="2543521050" sldId="267"/>
         </pc:sldMkLst>
-        <pc:spChg chg="del mod">
-          <ac:chgData name="Maxime Saffon" userId="25515bfe69c2a72d" providerId="LiveId" clId="{49065972-5317-42B7-8774-121C1DC3676C}" dt="2025-05-19T10:20:55.425" v="5" actId="478"/>
-          <ac:spMkLst>
-            <pc:docMk/>
-            <pc:sldMk cId="2543521050" sldId="267"/>
-            <ac:spMk id="6" creationId="{023A00A0-F05B-9CF8-DB5A-314C7DE13CE2}"/>
-          </ac:spMkLst>
-        </pc:spChg>
-        <pc:picChg chg="add del mod">
-          <ac:chgData name="Maxime Saffon" userId="25515bfe69c2a72d" providerId="LiveId" clId="{49065972-5317-42B7-8774-121C1DC3676C}" dt="2025-05-19T10:21:17.838" v="8" actId="478"/>
-          <ac:picMkLst>
-            <pc:docMk/>
-            <pc:sldMk cId="2543521050" sldId="267"/>
-            <ac:picMk id="1026" creationId="{E07A7923-20A0-9D11-2BD4-EB27B8F84EC1}"/>
-          </ac:picMkLst>
-        </pc:picChg>
         <pc:picChg chg="add mod">
           <ac:chgData name="Maxime Saffon" userId="25515bfe69c2a72d" providerId="LiveId" clId="{49065972-5317-42B7-8774-121C1DC3676C}" dt="2025-05-19T10:21:23.856" v="11" actId="1076"/>
           <ac:picMkLst>
             <pc:docMk/>
             <pc:sldMk cId="2543521050" sldId="267"/>
             <ac:picMk id="1028" creationId="{F637F614-F401-8D82-3007-C77FC7EFC303}"/>
+          </ac:picMkLst>
+        </pc:picChg>
+      </pc:sldChg>
+      <pc:sldChg chg="modSp mod">
+        <pc:chgData name="Maxime Saffon" userId="25515bfe69c2a72d" providerId="LiveId" clId="{49065972-5317-42B7-8774-121C1DC3676C}" dt="2025-05-26T10:45:16.982" v="28" actId="1036"/>
+        <pc:sldMkLst>
+          <pc:docMk/>
+          <pc:sldMk cId="4164114872" sldId="272"/>
+        </pc:sldMkLst>
+        <pc:picChg chg="mod">
+          <ac:chgData name="Maxime Saffon" userId="25515bfe69c2a72d" providerId="LiveId" clId="{49065972-5317-42B7-8774-121C1DC3676C}" dt="2025-05-26T10:45:16.982" v="28" actId="1036"/>
+          <ac:picMkLst>
+            <pc:docMk/>
+            <pc:sldMk cId="4164114872" sldId="272"/>
+            <ac:picMk id="5" creationId="{50423B6B-1FBA-2383-E34D-CF5EBE7979A0}"/>
+          </ac:picMkLst>
+        </pc:picChg>
+      </pc:sldChg>
+      <pc:sldChg chg="modSp">
+        <pc:chgData name="Maxime Saffon" userId="25515bfe69c2a72d" providerId="LiveId" clId="{49065972-5317-42B7-8774-121C1DC3676C}" dt="2025-05-26T12:46:06.839" v="33" actId="1076"/>
+        <pc:sldMkLst>
+          <pc:docMk/>
+          <pc:sldMk cId="4105236305" sldId="281"/>
+        </pc:sldMkLst>
+        <pc:picChg chg="mod">
+          <ac:chgData name="Maxime Saffon" userId="25515bfe69c2a72d" providerId="LiveId" clId="{49065972-5317-42B7-8774-121C1DC3676C}" dt="2025-05-26T12:46:06.839" v="33" actId="1076"/>
+          <ac:picMkLst>
+            <pc:docMk/>
+            <pc:sldMk cId="4105236305" sldId="281"/>
+            <ac:picMk id="14342" creationId="{5BF06CF9-F7A5-8491-B8F7-B00FF30EFB3B}"/>
           </ac:picMkLst>
         </pc:picChg>
       </pc:sldChg>
@@ -368,7 +382,7 @@
           <a:p>
             <a:fld id="{839A69C3-06C6-4ABB-B8A0-8EFC5B14A64C}" type="datetimeFigureOut">
               <a:rPr lang="en-HK" smtClean="0"/>
-              <a:t>19/5/2025</a:t>
+              <a:t>26/5/2025</a:t>
             </a:fld>
             <a:endParaRPr lang="en-HK"/>
           </a:p>
@@ -568,7 +582,7 @@
           <a:p>
             <a:fld id="{839A69C3-06C6-4ABB-B8A0-8EFC5B14A64C}" type="datetimeFigureOut">
               <a:rPr lang="en-HK" smtClean="0"/>
-              <a:t>19/5/2025</a:t>
+              <a:t>26/5/2025</a:t>
             </a:fld>
             <a:endParaRPr lang="en-HK"/>
           </a:p>
@@ -778,7 +792,7 @@
           <a:p>
             <a:fld id="{839A69C3-06C6-4ABB-B8A0-8EFC5B14A64C}" type="datetimeFigureOut">
               <a:rPr lang="en-HK" smtClean="0"/>
-              <a:t>19/5/2025</a:t>
+              <a:t>26/5/2025</a:t>
             </a:fld>
             <a:endParaRPr lang="en-HK"/>
           </a:p>
@@ -978,7 +992,7 @@
           <a:p>
             <a:fld id="{839A69C3-06C6-4ABB-B8A0-8EFC5B14A64C}" type="datetimeFigureOut">
               <a:rPr lang="en-HK" smtClean="0"/>
-              <a:t>19/5/2025</a:t>
+              <a:t>26/5/2025</a:t>
             </a:fld>
             <a:endParaRPr lang="en-HK"/>
           </a:p>
@@ -1254,7 +1268,7 @@
           <a:p>
             <a:fld id="{839A69C3-06C6-4ABB-B8A0-8EFC5B14A64C}" type="datetimeFigureOut">
               <a:rPr lang="en-HK" smtClean="0"/>
-              <a:t>19/5/2025</a:t>
+              <a:t>26/5/2025</a:t>
             </a:fld>
             <a:endParaRPr lang="en-HK"/>
           </a:p>
@@ -1522,7 +1536,7 @@
           <a:p>
             <a:fld id="{839A69C3-06C6-4ABB-B8A0-8EFC5B14A64C}" type="datetimeFigureOut">
               <a:rPr lang="en-HK" smtClean="0"/>
-              <a:t>19/5/2025</a:t>
+              <a:t>26/5/2025</a:t>
             </a:fld>
             <a:endParaRPr lang="en-HK"/>
           </a:p>
@@ -1937,7 +1951,7 @@
           <a:p>
             <a:fld id="{839A69C3-06C6-4ABB-B8A0-8EFC5B14A64C}" type="datetimeFigureOut">
               <a:rPr lang="en-HK" smtClean="0"/>
-              <a:t>19/5/2025</a:t>
+              <a:t>26/5/2025</a:t>
             </a:fld>
             <a:endParaRPr lang="en-HK"/>
           </a:p>
@@ -2079,7 +2093,7 @@
           <a:p>
             <a:fld id="{839A69C3-06C6-4ABB-B8A0-8EFC5B14A64C}" type="datetimeFigureOut">
               <a:rPr lang="en-HK" smtClean="0"/>
-              <a:t>19/5/2025</a:t>
+              <a:t>26/5/2025</a:t>
             </a:fld>
             <a:endParaRPr lang="en-HK"/>
           </a:p>
@@ -2192,7 +2206,7 @@
           <a:p>
             <a:fld id="{839A69C3-06C6-4ABB-B8A0-8EFC5B14A64C}" type="datetimeFigureOut">
               <a:rPr lang="en-HK" smtClean="0"/>
-              <a:t>19/5/2025</a:t>
+              <a:t>26/5/2025</a:t>
             </a:fld>
             <a:endParaRPr lang="en-HK"/>
           </a:p>
@@ -2505,7 +2519,7 @@
           <a:p>
             <a:fld id="{839A69C3-06C6-4ABB-B8A0-8EFC5B14A64C}" type="datetimeFigureOut">
               <a:rPr lang="en-HK" smtClean="0"/>
-              <a:t>19/5/2025</a:t>
+              <a:t>26/5/2025</a:t>
             </a:fld>
             <a:endParaRPr lang="en-HK"/>
           </a:p>
@@ -2794,7 +2808,7 @@
           <a:p>
             <a:fld id="{839A69C3-06C6-4ABB-B8A0-8EFC5B14A64C}" type="datetimeFigureOut">
               <a:rPr lang="en-HK" smtClean="0"/>
-              <a:t>19/5/2025</a:t>
+              <a:t>26/5/2025</a:t>
             </a:fld>
             <a:endParaRPr lang="en-HK"/>
           </a:p>
@@ -3037,7 +3051,7 @@
           <a:p>
             <a:fld id="{839A69C3-06C6-4ABB-B8A0-8EFC5B14A64C}" type="datetimeFigureOut">
               <a:rPr lang="en-HK" smtClean="0"/>
-              <a:t>19/5/2025</a:t>
+              <a:t>26/5/2025</a:t>
             </a:fld>
             <a:endParaRPr lang="en-HK"/>
           </a:p>
@@ -8716,8 +8730,8 @@
         </p:blipFill>
         <p:spPr bwMode="auto">
           <a:xfrm>
-            <a:off x="2286000" y="3805301"/>
-            <a:ext cx="7620000" cy="2952750"/>
+            <a:off x="-2949934" y="857320"/>
+            <a:ext cx="13273185" cy="5143359"/>
           </a:xfrm>
           <a:prstGeom prst="rect">
             <a:avLst/>

</xml_diff>